<commit_message>
feat: revisi ppt docs
</commit_message>
<xml_diff>
--- a/Docs/PPT_Docs.pptx
+++ b/Docs/PPT_Docs.pptx
@@ -14,21 +14,22 @@
     <p:sldId id="262" r:id="rId12"/>
     <p:sldId id="263" r:id="rId13"/>
     <p:sldId id="264" r:id="rId14"/>
+    <p:sldId id="265" r:id="rId15"/>
   </p:sldIdLst>
   <p:sldSz cx="18288000" cy="10287000"/>
   <p:notesSz cx="6858000" cy="9144000"/>
   <p:embeddedFontLst>
     <p:embeddedFont>
       <p:font typeface="League Spartan" charset="1" panose="00000800000000000000"/>
-      <p:regular r:id="rId15"/>
+      <p:regular r:id="rId16"/>
     </p:embeddedFont>
     <p:embeddedFont>
       <p:font typeface="Arimo Bold" charset="1" panose="020B0704020202020204"/>
-      <p:regular r:id="rId16"/>
+      <p:regular r:id="rId17"/>
     </p:embeddedFont>
     <p:embeddedFont>
       <p:font typeface="Arimo" charset="1" panose="020B0604020202020204"/>
-      <p:regular r:id="rId17"/>
+      <p:regular r:id="rId18"/>
     </p:embeddedFont>
   </p:embeddedFontLst>
   <p:defaultTextStyle>
@@ -3921,6 +3922,290 @@
                 <a:sym typeface="Arimo Bold"/>
               </a:rPr>
               <a:t>Absen: 07</a:t>
+            </a:r>
+          </a:p>
+        </p:txBody>
+      </p:sp>
+    </p:spTree>
+  </p:cSld>
+  <p:clrMapOvr>
+    <a:masterClrMapping/>
+  </p:clrMapOvr>
+</p:sld>
+</file>
+
+<file path=ppt/slides/slide10.xml><?xml version="1.0" encoding="utf-8"?>
+<p:sld xmlns:p="http://schemas.openxmlformats.org/presentationml/2006/main" xmlns:a="http://schemas.openxmlformats.org/drawingml/2006/main" xmlns:r="http://schemas.openxmlformats.org/officeDocument/2006/relationships">
+  <p:cSld>
+    <p:bg>
+      <p:bgPr>
+        <a:solidFill>
+          <a:srgbClr val="23354B"/>
+        </a:solidFill>
+      </p:bgPr>
+    </p:bg>
+    <p:spTree>
+      <p:nvGrpSpPr>
+        <p:cNvPr id="1" name=""/>
+        <p:cNvGrpSpPr/>
+        <p:nvPr/>
+      </p:nvGrpSpPr>
+      <p:grpSpPr>
+        <a:xfrm>
+          <a:off x="0" y="0"/>
+          <a:ext cx="0" cy="0"/>
+          <a:chOff x="0" y="0"/>
+          <a:chExt cx="0" cy="0"/>
+        </a:xfrm>
+      </p:grpSpPr>
+      <p:sp>
+        <p:nvSpPr>
+          <p:cNvPr name="Freeform 2" id="2"/>
+          <p:cNvSpPr/>
+          <p:nvPr/>
+        </p:nvSpPr>
+        <p:spPr>
+          <a:xfrm flipH="false" flipV="false" rot="0">
+            <a:off x="15537499" y="408799"/>
+            <a:ext cx="1487448" cy="1929472"/>
+          </a:xfrm>
+          <a:custGeom>
+            <a:avLst/>
+            <a:gdLst/>
+            <a:ahLst/>
+            <a:cxnLst/>
+            <a:rect r="r" b="b" t="t" l="l"/>
+            <a:pathLst>
+              <a:path h="1929472" w="1487448">
+                <a:moveTo>
+                  <a:pt x="0" y="0"/>
+                </a:moveTo>
+                <a:lnTo>
+                  <a:pt x="1487447" y="0"/>
+                </a:lnTo>
+                <a:lnTo>
+                  <a:pt x="1487447" y="1929472"/>
+                </a:lnTo>
+                <a:lnTo>
+                  <a:pt x="0" y="1929472"/>
+                </a:lnTo>
+                <a:lnTo>
+                  <a:pt x="0" y="0"/>
+                </a:lnTo>
+                <a:close/>
+              </a:path>
+            </a:pathLst>
+          </a:custGeom>
+          <a:blipFill>
+            <a:blip r:embed="rId2">
+              <a:extLst>
+                <a:ext uri="{96DAC541-7B7A-43D3-8B79-37D633B846F1}">
+                  <asvg:svgBlip xmlns:asvg="http://schemas.microsoft.com/office/drawing/2016/SVG/main" r:embed="rId3"/>
+                </a:ext>
+              </a:extLst>
+            </a:blip>
+            <a:stretch>
+              <a:fillRect l="0" t="0" r="0" b="0"/>
+            </a:stretch>
+          </a:blipFill>
+        </p:spPr>
+      </p:sp>
+      <p:sp>
+        <p:nvSpPr>
+          <p:cNvPr name="Freeform 3" id="3"/>
+          <p:cNvSpPr/>
+          <p:nvPr/>
+        </p:nvSpPr>
+        <p:spPr>
+          <a:xfrm flipH="false" flipV="false" rot="0">
+            <a:off x="787293" y="7753458"/>
+            <a:ext cx="1487448" cy="1929472"/>
+          </a:xfrm>
+          <a:custGeom>
+            <a:avLst/>
+            <a:gdLst/>
+            <a:ahLst/>
+            <a:cxnLst/>
+            <a:rect r="r" b="b" t="t" l="l"/>
+            <a:pathLst>
+              <a:path h="1929472" w="1487448">
+                <a:moveTo>
+                  <a:pt x="0" y="0"/>
+                </a:moveTo>
+                <a:lnTo>
+                  <a:pt x="1487448" y="0"/>
+                </a:lnTo>
+                <a:lnTo>
+                  <a:pt x="1487448" y="1929473"/>
+                </a:lnTo>
+                <a:lnTo>
+                  <a:pt x="0" y="1929473"/>
+                </a:lnTo>
+                <a:lnTo>
+                  <a:pt x="0" y="0"/>
+                </a:lnTo>
+                <a:close/>
+              </a:path>
+            </a:pathLst>
+          </a:custGeom>
+          <a:blipFill>
+            <a:blip r:embed="rId2">
+              <a:extLst>
+                <a:ext uri="{96DAC541-7B7A-43D3-8B79-37D633B846F1}">
+                  <asvg:svgBlip xmlns:asvg="http://schemas.microsoft.com/office/drawing/2016/SVG/main" r:embed="rId3"/>
+                </a:ext>
+              </a:extLst>
+            </a:blip>
+            <a:stretch>
+              <a:fillRect l="0" t="0" r="0" b="0"/>
+            </a:stretch>
+          </a:blipFill>
+        </p:spPr>
+      </p:sp>
+      <p:sp>
+        <p:nvSpPr>
+          <p:cNvPr name="Freeform 4" id="4"/>
+          <p:cNvSpPr/>
+          <p:nvPr/>
+        </p:nvSpPr>
+        <p:spPr>
+          <a:xfrm flipH="false" flipV="false" rot="5400000">
+            <a:off x="1892260" y="845119"/>
+            <a:ext cx="764962" cy="2168706"/>
+          </a:xfrm>
+          <a:custGeom>
+            <a:avLst/>
+            <a:gdLst/>
+            <a:ahLst/>
+            <a:cxnLst/>
+            <a:rect r="r" b="b" t="t" l="l"/>
+            <a:pathLst>
+              <a:path h="2168706" w="764962">
+                <a:moveTo>
+                  <a:pt x="0" y="0"/>
+                </a:moveTo>
+                <a:lnTo>
+                  <a:pt x="764962" y="0"/>
+                </a:lnTo>
+                <a:lnTo>
+                  <a:pt x="764962" y="2168707"/>
+                </a:lnTo>
+                <a:lnTo>
+                  <a:pt x="0" y="2168707"/>
+                </a:lnTo>
+                <a:lnTo>
+                  <a:pt x="0" y="0"/>
+                </a:lnTo>
+                <a:close/>
+              </a:path>
+            </a:pathLst>
+          </a:custGeom>
+          <a:blipFill>
+            <a:blip r:embed="rId4">
+              <a:extLst>
+                <a:ext uri="{96DAC541-7B7A-43D3-8B79-37D633B846F1}">
+                  <asvg:svgBlip xmlns:asvg="http://schemas.microsoft.com/office/drawing/2016/SVG/main" r:embed="rId5"/>
+                </a:ext>
+              </a:extLst>
+            </a:blip>
+            <a:stretch>
+              <a:fillRect l="0" t="0" r="0" b="0"/>
+            </a:stretch>
+          </a:blipFill>
+        </p:spPr>
+      </p:sp>
+      <p:sp>
+        <p:nvSpPr>
+          <p:cNvPr name="Freeform 5" id="5"/>
+          <p:cNvSpPr/>
+          <p:nvPr/>
+        </p:nvSpPr>
+        <p:spPr>
+          <a:xfrm flipH="true" flipV="true" rot="5400000">
+            <a:off x="15155018" y="7251361"/>
+            <a:ext cx="764962" cy="2168706"/>
+          </a:xfrm>
+          <a:custGeom>
+            <a:avLst/>
+            <a:gdLst/>
+            <a:ahLst/>
+            <a:cxnLst/>
+            <a:rect r="r" b="b" t="t" l="l"/>
+            <a:pathLst>
+              <a:path h="2168706" w="764962">
+                <a:moveTo>
+                  <a:pt x="764961" y="2168706"/>
+                </a:moveTo>
+                <a:lnTo>
+                  <a:pt x="0" y="2168706"/>
+                </a:lnTo>
+                <a:lnTo>
+                  <a:pt x="0" y="0"/>
+                </a:lnTo>
+                <a:lnTo>
+                  <a:pt x="764961" y="0"/>
+                </a:lnTo>
+                <a:lnTo>
+                  <a:pt x="764961" y="2168706"/>
+                </a:lnTo>
+                <a:close/>
+              </a:path>
+            </a:pathLst>
+          </a:custGeom>
+          <a:blipFill>
+            <a:blip r:embed="rId4">
+              <a:extLst>
+                <a:ext uri="{96DAC541-7B7A-43D3-8B79-37D633B846F1}">
+                  <asvg:svgBlip xmlns:asvg="http://schemas.microsoft.com/office/drawing/2016/SVG/main" r:embed="rId5"/>
+                </a:ext>
+              </a:extLst>
+            </a:blip>
+            <a:stretch>
+              <a:fillRect l="0" t="0" r="0" b="0"/>
+            </a:stretch>
+          </a:blipFill>
+        </p:spPr>
+      </p:sp>
+      <p:sp>
+        <p:nvSpPr>
+          <p:cNvPr name="TextBox 6" id="6"/>
+          <p:cNvSpPr txBox="true"/>
+          <p:nvPr/>
+        </p:nvSpPr>
+        <p:spPr>
+          <a:xfrm rot="0">
+            <a:off x="2168611" y="3767021"/>
+            <a:ext cx="13950777" cy="2476733"/>
+          </a:xfrm>
+          <a:prstGeom prst="rect">
+            <a:avLst/>
+          </a:prstGeom>
+        </p:spPr>
+        <p:txBody>
+          <a:bodyPr anchor="t" rtlCol="false" tIns="0" lIns="0" bIns="0" rIns="0">
+            <a:spAutoFit/>
+          </a:bodyPr>
+          <a:lstStyle/>
+          <a:p>
+            <a:pPr algn="ctr">
+              <a:lnSpc>
+                <a:spcPts val="20299"/>
+              </a:lnSpc>
+              <a:spcBef>
+                <a:spcPct val="0"/>
+              </a:spcBef>
+            </a:pPr>
+            <a:r>
+              <a:rPr lang="en-US" sz="14499">
+                <a:solidFill>
+                  <a:srgbClr val="FFFFFF"/>
+                </a:solidFill>
+                <a:latin typeface="League Spartan"/>
+                <a:ea typeface="League Spartan"/>
+                <a:cs typeface="League Spartan"/>
+                <a:sym typeface="League Spartan"/>
+              </a:rPr>
+              <a:t>Terima Kasih</a:t>
             </a:r>
           </a:p>
         </p:txBody>
@@ -8112,6 +8397,549 @@
     <p:bg>
       <p:bgPr>
         <a:solidFill>
+          <a:srgbClr val="23354B"/>
+        </a:solidFill>
+      </p:bgPr>
+    </p:bg>
+    <p:spTree>
+      <p:nvGrpSpPr>
+        <p:cNvPr id="1" name=""/>
+        <p:cNvGrpSpPr/>
+        <p:nvPr/>
+      </p:nvGrpSpPr>
+      <p:grpSpPr>
+        <a:xfrm>
+          <a:off x="0" y="0"/>
+          <a:ext cx="0" cy="0"/>
+          <a:chOff x="0" y="0"/>
+          <a:chExt cx="0" cy="0"/>
+        </a:xfrm>
+      </p:grpSpPr>
+      <p:grpSp>
+        <p:nvGrpSpPr>
+          <p:cNvPr name="Group 2" id="2"/>
+          <p:cNvGrpSpPr/>
+          <p:nvPr/>
+        </p:nvGrpSpPr>
+        <p:grpSpPr>
+          <a:xfrm rot="0">
+            <a:off x="1028700" y="2830245"/>
+            <a:ext cx="16230600" cy="6428055"/>
+            <a:chOff x="0" y="0"/>
+            <a:chExt cx="4274726" cy="1692986"/>
+          </a:xfrm>
+        </p:grpSpPr>
+        <p:sp>
+          <p:nvSpPr>
+            <p:cNvPr name="Freeform 3" id="3"/>
+            <p:cNvSpPr/>
+            <p:nvPr/>
+          </p:nvSpPr>
+          <p:spPr>
+            <a:xfrm flipH="false" flipV="false" rot="0">
+              <a:off x="0" y="0"/>
+              <a:ext cx="4274726" cy="1692986"/>
+            </a:xfrm>
+            <a:custGeom>
+              <a:avLst/>
+              <a:gdLst/>
+              <a:ahLst/>
+              <a:cxnLst/>
+              <a:rect r="r" b="b" t="t" l="l"/>
+              <a:pathLst>
+                <a:path h="1692986" w="4274726">
+                  <a:moveTo>
+                    <a:pt x="0" y="0"/>
+                  </a:moveTo>
+                  <a:lnTo>
+                    <a:pt x="4274726" y="0"/>
+                  </a:lnTo>
+                  <a:lnTo>
+                    <a:pt x="4274726" y="1692986"/>
+                  </a:lnTo>
+                  <a:lnTo>
+                    <a:pt x="0" y="1692986"/>
+                  </a:lnTo>
+                  <a:close/>
+                </a:path>
+              </a:pathLst>
+            </a:custGeom>
+            <a:solidFill>
+              <a:srgbClr val="FFFFFF"/>
+            </a:solidFill>
+          </p:spPr>
+        </p:sp>
+        <p:sp>
+          <p:nvSpPr>
+            <p:cNvPr name="TextBox 4" id="4"/>
+            <p:cNvSpPr txBox="true"/>
+            <p:nvPr/>
+          </p:nvSpPr>
+          <p:spPr>
+            <a:xfrm>
+              <a:off x="0" y="-47625"/>
+              <a:ext cx="4274726" cy="1740611"/>
+            </a:xfrm>
+            <a:prstGeom prst="rect">
+              <a:avLst/>
+            </a:prstGeom>
+          </p:spPr>
+          <p:txBody>
+            <a:bodyPr anchor="ctr" rtlCol="false" tIns="50800" lIns="50800" bIns="50800" rIns="50800"/>
+            <a:lstStyle/>
+            <a:p>
+              <a:pPr algn="ctr">
+                <a:lnSpc>
+                  <a:spcPts val="2659"/>
+                </a:lnSpc>
+              </a:pPr>
+            </a:p>
+          </p:txBody>
+        </p:sp>
+      </p:grpSp>
+      <p:sp>
+        <p:nvSpPr>
+          <p:cNvPr name="TextBox 5" id="5"/>
+          <p:cNvSpPr txBox="true"/>
+          <p:nvPr/>
+        </p:nvSpPr>
+        <p:spPr>
+          <a:xfrm rot="0">
+            <a:off x="1133049" y="2914825"/>
+            <a:ext cx="16021903" cy="6093350"/>
+          </a:xfrm>
+          <a:prstGeom prst="rect">
+            <a:avLst/>
+          </a:prstGeom>
+        </p:spPr>
+        <p:txBody>
+          <a:bodyPr anchor="t" rtlCol="false" tIns="0" lIns="0" bIns="0" rIns="0">
+            <a:spAutoFit/>
+          </a:bodyPr>
+          <a:lstStyle/>
+          <a:p>
+            <a:pPr algn="l">
+              <a:lnSpc>
+                <a:spcPts val="4871"/>
+              </a:lnSpc>
+            </a:pPr>
+            <a:r>
+              <a:rPr lang="en-US" sz="3479" b="true">
+                <a:solidFill>
+                  <a:srgbClr val="23354B"/>
+                </a:solidFill>
+                <a:latin typeface="Arimo Bold"/>
+                <a:ea typeface="Arimo Bold"/>
+                <a:cs typeface="Arimo Bold"/>
+                <a:sym typeface="Arimo Bold"/>
+              </a:rPr>
+              <a:t>AI yang digunakan</a:t>
+            </a:r>
+            <a:r>
+              <a:rPr lang="en-US" sz="3479">
+                <a:solidFill>
+                  <a:srgbClr val="23354B"/>
+                </a:solidFill>
+                <a:latin typeface="Arimo"/>
+                <a:ea typeface="Arimo"/>
+                <a:cs typeface="Arimo"/>
+                <a:sym typeface="Arimo"/>
+              </a:rPr>
+              <a:t> : Gemini 3 Flash</a:t>
+            </a:r>
+          </a:p>
+          <a:p>
+            <a:pPr algn="l">
+              <a:lnSpc>
+                <a:spcPts val="4871"/>
+              </a:lnSpc>
+            </a:pPr>
+          </a:p>
+          <a:p>
+            <a:pPr algn="l">
+              <a:lnSpc>
+                <a:spcPts val="4871"/>
+              </a:lnSpc>
+            </a:pPr>
+            <a:r>
+              <a:rPr lang="en-US" sz="3479" b="true">
+                <a:solidFill>
+                  <a:srgbClr val="23354B"/>
+                </a:solidFill>
+                <a:latin typeface="Arimo Bold"/>
+                <a:ea typeface="Arimo Bold"/>
+                <a:cs typeface="Arimo Bold"/>
+                <a:sym typeface="Arimo Bold"/>
+              </a:rPr>
+              <a:t>Prompt AI</a:t>
+            </a:r>
+            <a:r>
+              <a:rPr lang="en-US" sz="3479">
+                <a:solidFill>
+                  <a:srgbClr val="23354B"/>
+                </a:solidFill>
+                <a:latin typeface="Arimo"/>
+                <a:ea typeface="Arimo"/>
+                <a:cs typeface="Arimo"/>
+                <a:sym typeface="Arimo"/>
+              </a:rPr>
+              <a:t> : @laravel-expert fix JSON parsing failure in OpenRouterService</a:t>
+            </a:r>
+          </a:p>
+          <a:p>
+            <a:pPr algn="l">
+              <a:lnSpc>
+                <a:spcPts val="4871"/>
+              </a:lnSpc>
+            </a:pPr>
+          </a:p>
+          <a:p>
+            <a:pPr algn="l">
+              <a:lnSpc>
+                <a:spcPts val="4871"/>
+              </a:lnSpc>
+            </a:pPr>
+            <a:r>
+              <a:rPr lang="en-US" sz="3479" b="true">
+                <a:solidFill>
+                  <a:srgbClr val="23354B"/>
+                </a:solidFill>
+                <a:latin typeface="Arimo Bold"/>
+                <a:ea typeface="Arimo Bold"/>
+                <a:cs typeface="Arimo Bold"/>
+                <a:sym typeface="Arimo Bold"/>
+              </a:rPr>
+              <a:t>Hasil AI</a:t>
+            </a:r>
+            <a:r>
+              <a:rPr lang="en-US" sz="3479">
+                <a:solidFill>
+                  <a:srgbClr val="23354B"/>
+                </a:solidFill>
+                <a:latin typeface="Arimo"/>
+                <a:ea typeface="Arimo"/>
+                <a:cs typeface="Arimo"/>
+                <a:sym typeface="Arimo"/>
+              </a:rPr>
+              <a:t> : Implementasi regex sanitizer otomatis untuk membersihkan backtick Markdown.</a:t>
+            </a:r>
+          </a:p>
+          <a:p>
+            <a:pPr algn="l">
+              <a:lnSpc>
+                <a:spcPts val="4871"/>
+              </a:lnSpc>
+            </a:pPr>
+          </a:p>
+          <a:p>
+            <a:pPr algn="l">
+              <a:lnSpc>
+                <a:spcPts val="4871"/>
+              </a:lnSpc>
+            </a:pPr>
+            <a:r>
+              <a:rPr lang="en-US" sz="3479" b="true">
+                <a:solidFill>
+                  <a:srgbClr val="23354B"/>
+                </a:solidFill>
+                <a:latin typeface="Arimo Bold"/>
+                <a:ea typeface="Arimo Bold"/>
+                <a:cs typeface="Arimo Bold"/>
+                <a:sym typeface="Arimo Bold"/>
+              </a:rPr>
+              <a:t>Analisis </a:t>
+            </a:r>
+            <a:r>
+              <a:rPr lang="en-US" sz="3479">
+                <a:solidFill>
+                  <a:srgbClr val="23354B"/>
+                </a:solidFill>
+                <a:latin typeface="Arimo"/>
+                <a:ea typeface="Arimo"/>
+                <a:cs typeface="Arimo"/>
+                <a:sym typeface="Arimo"/>
+              </a:rPr>
+              <a:t>: AI sangat efektif untuk debugging struktural, namun membutuhkan audit logika manusia.</a:t>
+            </a:r>
+          </a:p>
+          <a:p>
+            <a:pPr algn="just">
+              <a:lnSpc>
+                <a:spcPts val="4871"/>
+              </a:lnSpc>
+              <a:spcBef>
+                <a:spcPct val="0"/>
+              </a:spcBef>
+            </a:pPr>
+          </a:p>
+        </p:txBody>
+      </p:sp>
+      <p:sp>
+        <p:nvSpPr>
+          <p:cNvPr name="Freeform 6" id="6"/>
+          <p:cNvSpPr/>
+          <p:nvPr/>
+        </p:nvSpPr>
+        <p:spPr>
+          <a:xfrm flipH="false" flipV="false" rot="0">
+            <a:off x="16621852" y="0"/>
+            <a:ext cx="1487448" cy="1929472"/>
+          </a:xfrm>
+          <a:custGeom>
+            <a:avLst/>
+            <a:gdLst/>
+            <a:ahLst/>
+            <a:cxnLst/>
+            <a:rect r="r" b="b" t="t" l="l"/>
+            <a:pathLst>
+              <a:path h="1929472" w="1487448">
+                <a:moveTo>
+                  <a:pt x="0" y="0"/>
+                </a:moveTo>
+                <a:lnTo>
+                  <a:pt x="1487448" y="0"/>
+                </a:lnTo>
+                <a:lnTo>
+                  <a:pt x="1487448" y="1929472"/>
+                </a:lnTo>
+                <a:lnTo>
+                  <a:pt x="0" y="1929472"/>
+                </a:lnTo>
+                <a:lnTo>
+                  <a:pt x="0" y="0"/>
+                </a:lnTo>
+                <a:close/>
+              </a:path>
+            </a:pathLst>
+          </a:custGeom>
+          <a:blipFill>
+            <a:blip r:embed="rId2">
+              <a:extLst>
+                <a:ext uri="{96DAC541-7B7A-43D3-8B79-37D633B846F1}">
+                  <asvg:svgBlip xmlns:asvg="http://schemas.microsoft.com/office/drawing/2016/SVG/main" r:embed="rId3"/>
+                </a:ext>
+              </a:extLst>
+            </a:blip>
+            <a:stretch>
+              <a:fillRect l="0" t="0" r="0" b="0"/>
+            </a:stretch>
+          </a:blipFill>
+        </p:spPr>
+      </p:sp>
+      <p:sp>
+        <p:nvSpPr>
+          <p:cNvPr name="TextBox 7" id="7"/>
+          <p:cNvSpPr txBox="true"/>
+          <p:nvPr/>
+        </p:nvSpPr>
+        <p:spPr>
+          <a:xfrm rot="0">
+            <a:off x="3073089" y="838200"/>
+            <a:ext cx="12141823" cy="1708151"/>
+          </a:xfrm>
+          <a:prstGeom prst="rect">
+            <a:avLst/>
+          </a:prstGeom>
+        </p:spPr>
+        <p:txBody>
+          <a:bodyPr anchor="t" rtlCol="false" tIns="0" lIns="0" bIns="0" rIns="0">
+            <a:spAutoFit/>
+          </a:bodyPr>
+          <a:lstStyle/>
+          <a:p>
+            <a:pPr algn="ctr">
+              <a:lnSpc>
+                <a:spcPts val="13999"/>
+              </a:lnSpc>
+              <a:spcBef>
+                <a:spcPct val="0"/>
+              </a:spcBef>
+            </a:pPr>
+            <a:r>
+              <a:rPr lang="en-US" sz="9999">
+                <a:solidFill>
+                  <a:srgbClr val="FFFFFF"/>
+                </a:solidFill>
+                <a:latin typeface="League Spartan"/>
+                <a:ea typeface="League Spartan"/>
+                <a:cs typeface="League Spartan"/>
+                <a:sym typeface="League Spartan"/>
+              </a:rPr>
+              <a:t>Penggunaan AI</a:t>
+            </a:r>
+          </a:p>
+        </p:txBody>
+      </p:sp>
+      <p:sp>
+        <p:nvSpPr>
+          <p:cNvPr name="Freeform 8" id="8"/>
+          <p:cNvSpPr/>
+          <p:nvPr/>
+        </p:nvSpPr>
+        <p:spPr>
+          <a:xfrm flipH="false" flipV="false" rot="0">
+            <a:off x="-297060" y="8718195"/>
+            <a:ext cx="1487448" cy="1929472"/>
+          </a:xfrm>
+          <a:custGeom>
+            <a:avLst/>
+            <a:gdLst/>
+            <a:ahLst/>
+            <a:cxnLst/>
+            <a:rect r="r" b="b" t="t" l="l"/>
+            <a:pathLst>
+              <a:path h="1929472" w="1487448">
+                <a:moveTo>
+                  <a:pt x="0" y="0"/>
+                </a:moveTo>
+                <a:lnTo>
+                  <a:pt x="1487448" y="0"/>
+                </a:lnTo>
+                <a:lnTo>
+                  <a:pt x="1487448" y="1929472"/>
+                </a:lnTo>
+                <a:lnTo>
+                  <a:pt x="0" y="1929472"/>
+                </a:lnTo>
+                <a:lnTo>
+                  <a:pt x="0" y="0"/>
+                </a:lnTo>
+                <a:close/>
+              </a:path>
+            </a:pathLst>
+          </a:custGeom>
+          <a:blipFill>
+            <a:blip r:embed="rId2">
+              <a:extLst>
+                <a:ext uri="{96DAC541-7B7A-43D3-8B79-37D633B846F1}">
+                  <asvg:svgBlip xmlns:asvg="http://schemas.microsoft.com/office/drawing/2016/SVG/main" r:embed="rId3"/>
+                </a:ext>
+              </a:extLst>
+            </a:blip>
+            <a:stretch>
+              <a:fillRect l="0" t="0" r="0" b="0"/>
+            </a:stretch>
+          </a:blipFill>
+        </p:spPr>
+      </p:sp>
+      <p:sp>
+        <p:nvSpPr>
+          <p:cNvPr name="Freeform 9" id="9"/>
+          <p:cNvSpPr/>
+          <p:nvPr/>
+        </p:nvSpPr>
+        <p:spPr>
+          <a:xfrm flipH="false" flipV="false" rot="5400000">
+            <a:off x="807907" y="-438134"/>
+            <a:ext cx="764962" cy="2168706"/>
+          </a:xfrm>
+          <a:custGeom>
+            <a:avLst/>
+            <a:gdLst/>
+            <a:ahLst/>
+            <a:cxnLst/>
+            <a:rect r="r" b="b" t="t" l="l"/>
+            <a:pathLst>
+              <a:path h="2168706" w="764962">
+                <a:moveTo>
+                  <a:pt x="0" y="0"/>
+                </a:moveTo>
+                <a:lnTo>
+                  <a:pt x="764962" y="0"/>
+                </a:lnTo>
+                <a:lnTo>
+                  <a:pt x="764962" y="2168706"/>
+                </a:lnTo>
+                <a:lnTo>
+                  <a:pt x="0" y="2168706"/>
+                </a:lnTo>
+                <a:lnTo>
+                  <a:pt x="0" y="0"/>
+                </a:lnTo>
+                <a:close/>
+              </a:path>
+            </a:pathLst>
+          </a:custGeom>
+          <a:blipFill>
+            <a:blip r:embed="rId4">
+              <a:extLst>
+                <a:ext uri="{96DAC541-7B7A-43D3-8B79-37D633B846F1}">
+                  <asvg:svgBlip xmlns:asvg="http://schemas.microsoft.com/office/drawing/2016/SVG/main" r:embed="rId5"/>
+                </a:ext>
+              </a:extLst>
+            </a:blip>
+            <a:stretch>
+              <a:fillRect l="0" t="0" r="0" b="0"/>
+            </a:stretch>
+          </a:blipFill>
+        </p:spPr>
+      </p:sp>
+      <p:sp>
+        <p:nvSpPr>
+          <p:cNvPr name="Freeform 10" id="10"/>
+          <p:cNvSpPr/>
+          <p:nvPr/>
+        </p:nvSpPr>
+        <p:spPr>
+          <a:xfrm flipH="true" flipV="true" rot="5400000">
+            <a:off x="16239371" y="8665253"/>
+            <a:ext cx="764962" cy="2168706"/>
+          </a:xfrm>
+          <a:custGeom>
+            <a:avLst/>
+            <a:gdLst/>
+            <a:ahLst/>
+            <a:cxnLst/>
+            <a:rect r="r" b="b" t="t" l="l"/>
+            <a:pathLst>
+              <a:path h="2168706" w="764962">
+                <a:moveTo>
+                  <a:pt x="764962" y="2168706"/>
+                </a:moveTo>
+                <a:lnTo>
+                  <a:pt x="0" y="2168706"/>
+                </a:lnTo>
+                <a:lnTo>
+                  <a:pt x="0" y="0"/>
+                </a:lnTo>
+                <a:lnTo>
+                  <a:pt x="764962" y="0"/>
+                </a:lnTo>
+                <a:lnTo>
+                  <a:pt x="764962" y="2168706"/>
+                </a:lnTo>
+                <a:close/>
+              </a:path>
+            </a:pathLst>
+          </a:custGeom>
+          <a:blipFill>
+            <a:blip r:embed="rId4">
+              <a:extLst>
+                <a:ext uri="{96DAC541-7B7A-43D3-8B79-37D633B846F1}">
+                  <asvg:svgBlip xmlns:asvg="http://schemas.microsoft.com/office/drawing/2016/SVG/main" r:embed="rId5"/>
+                </a:ext>
+              </a:extLst>
+            </a:blip>
+            <a:stretch>
+              <a:fillRect l="0" t="0" r="0" b="0"/>
+            </a:stretch>
+          </a:blipFill>
+        </p:spPr>
+      </p:sp>
+    </p:spTree>
+  </p:cSld>
+  <p:clrMapOvr>
+    <a:masterClrMapping/>
+  </p:clrMapOvr>
+</p:sld>
+</file>
+
+<file path=ppt/slides/slide7.xml><?xml version="1.0" encoding="utf-8"?>
+<p:sld xmlns:p="http://schemas.openxmlformats.org/presentationml/2006/main" xmlns:a="http://schemas.openxmlformats.org/drawingml/2006/main" xmlns:r="http://schemas.openxmlformats.org/officeDocument/2006/relationships">
+  <p:cSld>
+    <p:bg>
+      <p:bgPr>
+        <a:solidFill>
           <a:srgbClr val="98B9E1"/>
         </a:solidFill>
       </p:bgPr>
@@ -8834,7 +9662,7 @@
 </p:sld>
 </file>
 
-<file path=ppt/slides/slide7.xml><?xml version="1.0" encoding="utf-8"?>
+<file path=ppt/slides/slide8.xml><?xml version="1.0" encoding="utf-8"?>
 <p:sld xmlns:p="http://schemas.openxmlformats.org/presentationml/2006/main" xmlns:a="http://schemas.openxmlformats.org/drawingml/2006/main" xmlns:r="http://schemas.openxmlformats.org/officeDocument/2006/relationships">
   <p:cSld>
     <p:bg>
@@ -9442,7 +10270,7 @@
 </p:sld>
 </file>
 
-<file path=ppt/slides/slide8.xml><?xml version="1.0" encoding="utf-8"?>
+<file path=ppt/slides/slide9.xml><?xml version="1.0" encoding="utf-8"?>
 <p:sld xmlns:p="http://schemas.openxmlformats.org/presentationml/2006/main" xmlns:a="http://schemas.openxmlformats.org/drawingml/2006/main" xmlns:r="http://schemas.openxmlformats.org/officeDocument/2006/relationships">
   <p:cSld>
     <p:spTree>
@@ -10051,290 +10879,6 @@
                 <a:sym typeface="League Spartan"/>
               </a:rPr>
               <a:t>https://github.com/Fauzan-Fz/Laravel_NexTugas</a:t>
-            </a:r>
-          </a:p>
-        </p:txBody>
-      </p:sp>
-    </p:spTree>
-  </p:cSld>
-  <p:clrMapOvr>
-    <a:masterClrMapping/>
-  </p:clrMapOvr>
-</p:sld>
-</file>
-
-<file path=ppt/slides/slide9.xml><?xml version="1.0" encoding="utf-8"?>
-<p:sld xmlns:p="http://schemas.openxmlformats.org/presentationml/2006/main" xmlns:a="http://schemas.openxmlformats.org/drawingml/2006/main" xmlns:r="http://schemas.openxmlformats.org/officeDocument/2006/relationships">
-  <p:cSld>
-    <p:bg>
-      <p:bgPr>
-        <a:solidFill>
-          <a:srgbClr val="23354B"/>
-        </a:solidFill>
-      </p:bgPr>
-    </p:bg>
-    <p:spTree>
-      <p:nvGrpSpPr>
-        <p:cNvPr id="1" name=""/>
-        <p:cNvGrpSpPr/>
-        <p:nvPr/>
-      </p:nvGrpSpPr>
-      <p:grpSpPr>
-        <a:xfrm>
-          <a:off x="0" y="0"/>
-          <a:ext cx="0" cy="0"/>
-          <a:chOff x="0" y="0"/>
-          <a:chExt cx="0" cy="0"/>
-        </a:xfrm>
-      </p:grpSpPr>
-      <p:sp>
-        <p:nvSpPr>
-          <p:cNvPr name="Freeform 2" id="2"/>
-          <p:cNvSpPr/>
-          <p:nvPr/>
-        </p:nvSpPr>
-        <p:spPr>
-          <a:xfrm flipH="false" flipV="false" rot="0">
-            <a:off x="15537499" y="408799"/>
-            <a:ext cx="1487448" cy="1929472"/>
-          </a:xfrm>
-          <a:custGeom>
-            <a:avLst/>
-            <a:gdLst/>
-            <a:ahLst/>
-            <a:cxnLst/>
-            <a:rect r="r" b="b" t="t" l="l"/>
-            <a:pathLst>
-              <a:path h="1929472" w="1487448">
-                <a:moveTo>
-                  <a:pt x="0" y="0"/>
-                </a:moveTo>
-                <a:lnTo>
-                  <a:pt x="1487447" y="0"/>
-                </a:lnTo>
-                <a:lnTo>
-                  <a:pt x="1487447" y="1929472"/>
-                </a:lnTo>
-                <a:lnTo>
-                  <a:pt x="0" y="1929472"/>
-                </a:lnTo>
-                <a:lnTo>
-                  <a:pt x="0" y="0"/>
-                </a:lnTo>
-                <a:close/>
-              </a:path>
-            </a:pathLst>
-          </a:custGeom>
-          <a:blipFill>
-            <a:blip r:embed="rId2">
-              <a:extLst>
-                <a:ext uri="{96DAC541-7B7A-43D3-8B79-37D633B846F1}">
-                  <asvg:svgBlip xmlns:asvg="http://schemas.microsoft.com/office/drawing/2016/SVG/main" r:embed="rId3"/>
-                </a:ext>
-              </a:extLst>
-            </a:blip>
-            <a:stretch>
-              <a:fillRect l="0" t="0" r="0" b="0"/>
-            </a:stretch>
-          </a:blipFill>
-        </p:spPr>
-      </p:sp>
-      <p:sp>
-        <p:nvSpPr>
-          <p:cNvPr name="Freeform 3" id="3"/>
-          <p:cNvSpPr/>
-          <p:nvPr/>
-        </p:nvSpPr>
-        <p:spPr>
-          <a:xfrm flipH="false" flipV="false" rot="0">
-            <a:off x="787293" y="7753458"/>
-            <a:ext cx="1487448" cy="1929472"/>
-          </a:xfrm>
-          <a:custGeom>
-            <a:avLst/>
-            <a:gdLst/>
-            <a:ahLst/>
-            <a:cxnLst/>
-            <a:rect r="r" b="b" t="t" l="l"/>
-            <a:pathLst>
-              <a:path h="1929472" w="1487448">
-                <a:moveTo>
-                  <a:pt x="0" y="0"/>
-                </a:moveTo>
-                <a:lnTo>
-                  <a:pt x="1487448" y="0"/>
-                </a:lnTo>
-                <a:lnTo>
-                  <a:pt x="1487448" y="1929473"/>
-                </a:lnTo>
-                <a:lnTo>
-                  <a:pt x="0" y="1929473"/>
-                </a:lnTo>
-                <a:lnTo>
-                  <a:pt x="0" y="0"/>
-                </a:lnTo>
-                <a:close/>
-              </a:path>
-            </a:pathLst>
-          </a:custGeom>
-          <a:blipFill>
-            <a:blip r:embed="rId2">
-              <a:extLst>
-                <a:ext uri="{96DAC541-7B7A-43D3-8B79-37D633B846F1}">
-                  <asvg:svgBlip xmlns:asvg="http://schemas.microsoft.com/office/drawing/2016/SVG/main" r:embed="rId3"/>
-                </a:ext>
-              </a:extLst>
-            </a:blip>
-            <a:stretch>
-              <a:fillRect l="0" t="0" r="0" b="0"/>
-            </a:stretch>
-          </a:blipFill>
-        </p:spPr>
-      </p:sp>
-      <p:sp>
-        <p:nvSpPr>
-          <p:cNvPr name="Freeform 4" id="4"/>
-          <p:cNvSpPr/>
-          <p:nvPr/>
-        </p:nvSpPr>
-        <p:spPr>
-          <a:xfrm flipH="false" flipV="false" rot="5400000">
-            <a:off x="1892260" y="845119"/>
-            <a:ext cx="764962" cy="2168706"/>
-          </a:xfrm>
-          <a:custGeom>
-            <a:avLst/>
-            <a:gdLst/>
-            <a:ahLst/>
-            <a:cxnLst/>
-            <a:rect r="r" b="b" t="t" l="l"/>
-            <a:pathLst>
-              <a:path h="2168706" w="764962">
-                <a:moveTo>
-                  <a:pt x="0" y="0"/>
-                </a:moveTo>
-                <a:lnTo>
-                  <a:pt x="764962" y="0"/>
-                </a:lnTo>
-                <a:lnTo>
-                  <a:pt x="764962" y="2168707"/>
-                </a:lnTo>
-                <a:lnTo>
-                  <a:pt x="0" y="2168707"/>
-                </a:lnTo>
-                <a:lnTo>
-                  <a:pt x="0" y="0"/>
-                </a:lnTo>
-                <a:close/>
-              </a:path>
-            </a:pathLst>
-          </a:custGeom>
-          <a:blipFill>
-            <a:blip r:embed="rId4">
-              <a:extLst>
-                <a:ext uri="{96DAC541-7B7A-43D3-8B79-37D633B846F1}">
-                  <asvg:svgBlip xmlns:asvg="http://schemas.microsoft.com/office/drawing/2016/SVG/main" r:embed="rId5"/>
-                </a:ext>
-              </a:extLst>
-            </a:blip>
-            <a:stretch>
-              <a:fillRect l="0" t="0" r="0" b="0"/>
-            </a:stretch>
-          </a:blipFill>
-        </p:spPr>
-      </p:sp>
-      <p:sp>
-        <p:nvSpPr>
-          <p:cNvPr name="Freeform 5" id="5"/>
-          <p:cNvSpPr/>
-          <p:nvPr/>
-        </p:nvSpPr>
-        <p:spPr>
-          <a:xfrm flipH="true" flipV="true" rot="5400000">
-            <a:off x="15155018" y="7251361"/>
-            <a:ext cx="764962" cy="2168706"/>
-          </a:xfrm>
-          <a:custGeom>
-            <a:avLst/>
-            <a:gdLst/>
-            <a:ahLst/>
-            <a:cxnLst/>
-            <a:rect r="r" b="b" t="t" l="l"/>
-            <a:pathLst>
-              <a:path h="2168706" w="764962">
-                <a:moveTo>
-                  <a:pt x="764961" y="2168706"/>
-                </a:moveTo>
-                <a:lnTo>
-                  <a:pt x="0" y="2168706"/>
-                </a:lnTo>
-                <a:lnTo>
-                  <a:pt x="0" y="0"/>
-                </a:lnTo>
-                <a:lnTo>
-                  <a:pt x="764961" y="0"/>
-                </a:lnTo>
-                <a:lnTo>
-                  <a:pt x="764961" y="2168706"/>
-                </a:lnTo>
-                <a:close/>
-              </a:path>
-            </a:pathLst>
-          </a:custGeom>
-          <a:blipFill>
-            <a:blip r:embed="rId4">
-              <a:extLst>
-                <a:ext uri="{96DAC541-7B7A-43D3-8B79-37D633B846F1}">
-                  <asvg:svgBlip xmlns:asvg="http://schemas.microsoft.com/office/drawing/2016/SVG/main" r:embed="rId5"/>
-                </a:ext>
-              </a:extLst>
-            </a:blip>
-            <a:stretch>
-              <a:fillRect l="0" t="0" r="0" b="0"/>
-            </a:stretch>
-          </a:blipFill>
-        </p:spPr>
-      </p:sp>
-      <p:sp>
-        <p:nvSpPr>
-          <p:cNvPr name="TextBox 6" id="6"/>
-          <p:cNvSpPr txBox="true"/>
-          <p:nvPr/>
-        </p:nvSpPr>
-        <p:spPr>
-          <a:xfrm rot="0">
-            <a:off x="2168611" y="3767021"/>
-            <a:ext cx="13950777" cy="2476733"/>
-          </a:xfrm>
-          <a:prstGeom prst="rect">
-            <a:avLst/>
-          </a:prstGeom>
-        </p:spPr>
-        <p:txBody>
-          <a:bodyPr anchor="t" rtlCol="false" tIns="0" lIns="0" bIns="0" rIns="0">
-            <a:spAutoFit/>
-          </a:bodyPr>
-          <a:lstStyle/>
-          <a:p>
-            <a:pPr algn="ctr">
-              <a:lnSpc>
-                <a:spcPts val="20299"/>
-              </a:lnSpc>
-              <a:spcBef>
-                <a:spcPct val="0"/>
-              </a:spcBef>
-            </a:pPr>
-            <a:r>
-              <a:rPr lang="en-US" sz="14499">
-                <a:solidFill>
-                  <a:srgbClr val="FFFFFF"/>
-                </a:solidFill>
-                <a:latin typeface="League Spartan"/>
-                <a:ea typeface="League Spartan"/>
-                <a:cs typeface="League Spartan"/>
-                <a:sym typeface="League Spartan"/>
-              </a:rPr>
-              <a:t>Terima Kasih</a:t>
             </a:r>
           </a:p>
         </p:txBody>

</xml_diff>